<commit_message>
FeDeV 2019 (final update)
Final version of powerpoint slides
</commit_message>
<xml_diff>
--- a/Communication/FeDeV 2019/misc/schema_experience.pptx
+++ b/Communication/FeDeV 2019/misc/schema_experience.pptx
@@ -6,6 +6,7 @@
   </p:sldMasterIdLst>
   <p:sldIdLst>
     <p:sldId id="256" r:id="rId2"/>
+    <p:sldId id="257" r:id="rId3"/>
   </p:sldIdLst>
   <p:sldSz cx="12192000" cy="6858000"/>
   <p:notesSz cx="6858000" cy="9144000"/>
@@ -104,6 +105,11 @@
       </a:defRPr>
     </a:lvl9pPr>
   </p:defaultTextStyle>
+  <p:extLst>
+    <p:ext uri="{EFAFB233-063F-42B5-8137-9DF3F51BA10A}">
+      <p15:sldGuideLst xmlns:p15="http://schemas.microsoft.com/office/powerpoint/2012/main"/>
+    </p:ext>
+  </p:extLst>
 </p:presentation>
 </file>
 
@@ -149,10 +155,9 @@
           </a:lstStyle>
           <a:p>
             <a:r>
-              <a:rPr lang="fr-FR" smtClean="0"/>
+              <a:rPr lang="fr-FR"/>
               <a:t>Modifiez le style du titre</a:t>
             </a:r>
-            <a:endParaRPr lang="fr-FR"/>
           </a:p>
         </p:txBody>
       </p:sp>
@@ -214,10 +219,9 @@
           </a:lstStyle>
           <a:p>
             <a:r>
-              <a:rPr lang="fr-FR" smtClean="0"/>
+              <a:rPr lang="fr-FR"/>
               <a:t>Modifier le style des sous-titres du masque</a:t>
             </a:r>
-            <a:endParaRPr lang="fr-FR"/>
           </a:p>
         </p:txBody>
       </p:sp>
@@ -238,7 +242,7 @@
           <a:p>
             <a:fld id="{3704A910-6F2B-4762-9270-65B2D88D615E}" type="datetimeFigureOut">
               <a:rPr lang="fr-FR" smtClean="0"/>
-              <a:t>30/09/2019</a:t>
+              <a:t>04/11/2019</a:t>
             </a:fld>
             <a:endParaRPr lang="fr-FR"/>
           </a:p>
@@ -332,10 +336,9 @@
           <a:lstStyle/>
           <a:p>
             <a:r>
-              <a:rPr lang="fr-FR" smtClean="0"/>
+              <a:rPr lang="fr-FR"/>
               <a:t>Modifiez le style du titre</a:t>
             </a:r>
-            <a:endParaRPr lang="fr-FR"/>
           </a:p>
         </p:txBody>
       </p:sp>
@@ -356,38 +359,37 @@
           <a:p>
             <a:pPr lvl="0"/>
             <a:r>
-              <a:rPr lang="fr-FR" smtClean="0"/>
+              <a:rPr lang="fr-FR"/>
               <a:t>Modifier les styles du texte du masque</a:t>
             </a:r>
           </a:p>
           <a:p>
             <a:pPr lvl="1"/>
             <a:r>
-              <a:rPr lang="fr-FR" smtClean="0"/>
+              <a:rPr lang="fr-FR"/>
               <a:t>Deuxième niveau</a:t>
             </a:r>
           </a:p>
           <a:p>
             <a:pPr lvl="2"/>
             <a:r>
-              <a:rPr lang="fr-FR" smtClean="0"/>
+              <a:rPr lang="fr-FR"/>
               <a:t>Troisième niveau</a:t>
             </a:r>
           </a:p>
           <a:p>
             <a:pPr lvl="3"/>
             <a:r>
-              <a:rPr lang="fr-FR" smtClean="0"/>
+              <a:rPr lang="fr-FR"/>
               <a:t>Quatrième niveau</a:t>
             </a:r>
           </a:p>
           <a:p>
             <a:pPr lvl="4"/>
             <a:r>
-              <a:rPr lang="fr-FR" smtClean="0"/>
+              <a:rPr lang="fr-FR"/>
               <a:t>Cinquième niveau</a:t>
             </a:r>
-            <a:endParaRPr lang="fr-FR"/>
           </a:p>
         </p:txBody>
       </p:sp>
@@ -408,7 +410,7 @@
           <a:p>
             <a:fld id="{3704A910-6F2B-4762-9270-65B2D88D615E}" type="datetimeFigureOut">
               <a:rPr lang="fr-FR" smtClean="0"/>
-              <a:t>30/09/2019</a:t>
+              <a:t>04/11/2019</a:t>
             </a:fld>
             <a:endParaRPr lang="fr-FR"/>
           </a:p>
@@ -507,10 +509,9 @@
           <a:lstStyle/>
           <a:p>
             <a:r>
-              <a:rPr lang="fr-FR" smtClean="0"/>
+              <a:rPr lang="fr-FR"/>
               <a:t>Modifiez le style du titre</a:t>
             </a:r>
-            <a:endParaRPr lang="fr-FR"/>
           </a:p>
         </p:txBody>
       </p:sp>
@@ -536,38 +537,37 @@
           <a:p>
             <a:pPr lvl="0"/>
             <a:r>
-              <a:rPr lang="fr-FR" smtClean="0"/>
+              <a:rPr lang="fr-FR"/>
               <a:t>Modifier les styles du texte du masque</a:t>
             </a:r>
           </a:p>
           <a:p>
             <a:pPr lvl="1"/>
             <a:r>
-              <a:rPr lang="fr-FR" smtClean="0"/>
+              <a:rPr lang="fr-FR"/>
               <a:t>Deuxième niveau</a:t>
             </a:r>
           </a:p>
           <a:p>
             <a:pPr lvl="2"/>
             <a:r>
-              <a:rPr lang="fr-FR" smtClean="0"/>
+              <a:rPr lang="fr-FR"/>
               <a:t>Troisième niveau</a:t>
             </a:r>
           </a:p>
           <a:p>
             <a:pPr lvl="3"/>
             <a:r>
-              <a:rPr lang="fr-FR" smtClean="0"/>
+              <a:rPr lang="fr-FR"/>
               <a:t>Quatrième niveau</a:t>
             </a:r>
           </a:p>
           <a:p>
             <a:pPr lvl="4"/>
             <a:r>
-              <a:rPr lang="fr-FR" smtClean="0"/>
+              <a:rPr lang="fr-FR"/>
               <a:t>Cinquième niveau</a:t>
             </a:r>
-            <a:endParaRPr lang="fr-FR"/>
           </a:p>
         </p:txBody>
       </p:sp>
@@ -588,7 +588,7 @@
           <a:p>
             <a:fld id="{3704A910-6F2B-4762-9270-65B2D88D615E}" type="datetimeFigureOut">
               <a:rPr lang="fr-FR" smtClean="0"/>
-              <a:t>30/09/2019</a:t>
+              <a:t>04/11/2019</a:t>
             </a:fld>
             <a:endParaRPr lang="fr-FR"/>
           </a:p>
@@ -682,10 +682,9 @@
           <a:lstStyle/>
           <a:p>
             <a:r>
-              <a:rPr lang="fr-FR" smtClean="0"/>
+              <a:rPr lang="fr-FR"/>
               <a:t>Modifiez le style du titre</a:t>
             </a:r>
-            <a:endParaRPr lang="fr-FR"/>
           </a:p>
         </p:txBody>
       </p:sp>
@@ -706,38 +705,37 @@
           <a:p>
             <a:pPr lvl="0"/>
             <a:r>
-              <a:rPr lang="fr-FR" smtClean="0"/>
+              <a:rPr lang="fr-FR"/>
               <a:t>Modifier les styles du texte du masque</a:t>
             </a:r>
           </a:p>
           <a:p>
             <a:pPr lvl="1"/>
             <a:r>
-              <a:rPr lang="fr-FR" smtClean="0"/>
+              <a:rPr lang="fr-FR"/>
               <a:t>Deuxième niveau</a:t>
             </a:r>
           </a:p>
           <a:p>
             <a:pPr lvl="2"/>
             <a:r>
-              <a:rPr lang="fr-FR" smtClean="0"/>
+              <a:rPr lang="fr-FR"/>
               <a:t>Troisième niveau</a:t>
             </a:r>
           </a:p>
           <a:p>
             <a:pPr lvl="3"/>
             <a:r>
-              <a:rPr lang="fr-FR" smtClean="0"/>
+              <a:rPr lang="fr-FR"/>
               <a:t>Quatrième niveau</a:t>
             </a:r>
           </a:p>
           <a:p>
             <a:pPr lvl="4"/>
             <a:r>
-              <a:rPr lang="fr-FR" smtClean="0"/>
+              <a:rPr lang="fr-FR"/>
               <a:t>Cinquième niveau</a:t>
             </a:r>
-            <a:endParaRPr lang="fr-FR"/>
           </a:p>
         </p:txBody>
       </p:sp>
@@ -758,7 +756,7 @@
           <a:p>
             <a:fld id="{3704A910-6F2B-4762-9270-65B2D88D615E}" type="datetimeFigureOut">
               <a:rPr lang="fr-FR" smtClean="0"/>
-              <a:t>30/09/2019</a:t>
+              <a:t>04/11/2019</a:t>
             </a:fld>
             <a:endParaRPr lang="fr-FR"/>
           </a:p>
@@ -861,10 +859,9 @@
           </a:lstStyle>
           <a:p>
             <a:r>
-              <a:rPr lang="fr-FR" smtClean="0"/>
+              <a:rPr lang="fr-FR"/>
               <a:t>Modifiez le style du titre</a:t>
             </a:r>
-            <a:endParaRPr lang="fr-FR"/>
           </a:p>
         </p:txBody>
       </p:sp>
@@ -981,7 +978,7 @@
           <a:p>
             <a:pPr lvl="0"/>
             <a:r>
-              <a:rPr lang="fr-FR" smtClean="0"/>
+              <a:rPr lang="fr-FR"/>
               <a:t>Modifier les styles du texte du masque</a:t>
             </a:r>
           </a:p>
@@ -1004,7 +1001,7 @@
           <a:p>
             <a:fld id="{3704A910-6F2B-4762-9270-65B2D88D615E}" type="datetimeFigureOut">
               <a:rPr lang="fr-FR" smtClean="0"/>
-              <a:t>30/09/2019</a:t>
+              <a:t>04/11/2019</a:t>
             </a:fld>
             <a:endParaRPr lang="fr-FR"/>
           </a:p>
@@ -1098,10 +1095,9 @@
           <a:lstStyle/>
           <a:p>
             <a:r>
-              <a:rPr lang="fr-FR" smtClean="0"/>
+              <a:rPr lang="fr-FR"/>
               <a:t>Modifiez le style du titre</a:t>
             </a:r>
-            <a:endParaRPr lang="fr-FR"/>
           </a:p>
         </p:txBody>
       </p:sp>
@@ -1127,38 +1123,37 @@
           <a:p>
             <a:pPr lvl="0"/>
             <a:r>
-              <a:rPr lang="fr-FR" smtClean="0"/>
+              <a:rPr lang="fr-FR"/>
               <a:t>Modifier les styles du texte du masque</a:t>
             </a:r>
           </a:p>
           <a:p>
             <a:pPr lvl="1"/>
             <a:r>
-              <a:rPr lang="fr-FR" smtClean="0"/>
+              <a:rPr lang="fr-FR"/>
               <a:t>Deuxième niveau</a:t>
             </a:r>
           </a:p>
           <a:p>
             <a:pPr lvl="2"/>
             <a:r>
-              <a:rPr lang="fr-FR" smtClean="0"/>
+              <a:rPr lang="fr-FR"/>
               <a:t>Troisième niveau</a:t>
             </a:r>
           </a:p>
           <a:p>
             <a:pPr lvl="3"/>
             <a:r>
-              <a:rPr lang="fr-FR" smtClean="0"/>
+              <a:rPr lang="fr-FR"/>
               <a:t>Quatrième niveau</a:t>
             </a:r>
           </a:p>
           <a:p>
             <a:pPr lvl="4"/>
             <a:r>
-              <a:rPr lang="fr-FR" smtClean="0"/>
+              <a:rPr lang="fr-FR"/>
               <a:t>Cinquième niveau</a:t>
             </a:r>
-            <a:endParaRPr lang="fr-FR"/>
           </a:p>
         </p:txBody>
       </p:sp>
@@ -1184,38 +1179,37 @@
           <a:p>
             <a:pPr lvl="0"/>
             <a:r>
-              <a:rPr lang="fr-FR" smtClean="0"/>
+              <a:rPr lang="fr-FR"/>
               <a:t>Modifier les styles du texte du masque</a:t>
             </a:r>
           </a:p>
           <a:p>
             <a:pPr lvl="1"/>
             <a:r>
-              <a:rPr lang="fr-FR" smtClean="0"/>
+              <a:rPr lang="fr-FR"/>
               <a:t>Deuxième niveau</a:t>
             </a:r>
           </a:p>
           <a:p>
             <a:pPr lvl="2"/>
             <a:r>
-              <a:rPr lang="fr-FR" smtClean="0"/>
+              <a:rPr lang="fr-FR"/>
               <a:t>Troisième niveau</a:t>
             </a:r>
           </a:p>
           <a:p>
             <a:pPr lvl="3"/>
             <a:r>
-              <a:rPr lang="fr-FR" smtClean="0"/>
+              <a:rPr lang="fr-FR"/>
               <a:t>Quatrième niveau</a:t>
             </a:r>
           </a:p>
           <a:p>
             <a:pPr lvl="4"/>
             <a:r>
-              <a:rPr lang="fr-FR" smtClean="0"/>
+              <a:rPr lang="fr-FR"/>
               <a:t>Cinquième niveau</a:t>
             </a:r>
-            <a:endParaRPr lang="fr-FR"/>
           </a:p>
         </p:txBody>
       </p:sp>
@@ -1236,7 +1230,7 @@
           <a:p>
             <a:fld id="{3704A910-6F2B-4762-9270-65B2D88D615E}" type="datetimeFigureOut">
               <a:rPr lang="fr-FR" smtClean="0"/>
-              <a:t>30/09/2019</a:t>
+              <a:t>04/11/2019</a:t>
             </a:fld>
             <a:endParaRPr lang="fr-FR"/>
           </a:p>
@@ -1335,10 +1329,9 @@
           <a:lstStyle/>
           <a:p>
             <a:r>
-              <a:rPr lang="fr-FR" smtClean="0"/>
+              <a:rPr lang="fr-FR"/>
               <a:t>Modifiez le style du titre</a:t>
             </a:r>
-            <a:endParaRPr lang="fr-FR"/>
           </a:p>
         </p:txBody>
       </p:sp>
@@ -1401,7 +1394,7 @@
           <a:p>
             <a:pPr lvl="0"/>
             <a:r>
-              <a:rPr lang="fr-FR" smtClean="0"/>
+              <a:rPr lang="fr-FR"/>
               <a:t>Modifier les styles du texte du masque</a:t>
             </a:r>
           </a:p>
@@ -1429,38 +1422,37 @@
           <a:p>
             <a:pPr lvl="0"/>
             <a:r>
-              <a:rPr lang="fr-FR" smtClean="0"/>
+              <a:rPr lang="fr-FR"/>
               <a:t>Modifier les styles du texte du masque</a:t>
             </a:r>
           </a:p>
           <a:p>
             <a:pPr lvl="1"/>
             <a:r>
-              <a:rPr lang="fr-FR" smtClean="0"/>
+              <a:rPr lang="fr-FR"/>
               <a:t>Deuxième niveau</a:t>
             </a:r>
           </a:p>
           <a:p>
             <a:pPr lvl="2"/>
             <a:r>
-              <a:rPr lang="fr-FR" smtClean="0"/>
+              <a:rPr lang="fr-FR"/>
               <a:t>Troisième niveau</a:t>
             </a:r>
           </a:p>
           <a:p>
             <a:pPr lvl="3"/>
             <a:r>
-              <a:rPr lang="fr-FR" smtClean="0"/>
+              <a:rPr lang="fr-FR"/>
               <a:t>Quatrième niveau</a:t>
             </a:r>
           </a:p>
           <a:p>
             <a:pPr lvl="4"/>
             <a:r>
-              <a:rPr lang="fr-FR" smtClean="0"/>
+              <a:rPr lang="fr-FR"/>
               <a:t>Cinquième niveau</a:t>
             </a:r>
-            <a:endParaRPr lang="fr-FR"/>
           </a:p>
         </p:txBody>
       </p:sp>
@@ -1523,7 +1515,7 @@
           <a:p>
             <a:pPr lvl="0"/>
             <a:r>
-              <a:rPr lang="fr-FR" smtClean="0"/>
+              <a:rPr lang="fr-FR"/>
               <a:t>Modifier les styles du texte du masque</a:t>
             </a:r>
           </a:p>
@@ -1551,38 +1543,37 @@
           <a:p>
             <a:pPr lvl="0"/>
             <a:r>
-              <a:rPr lang="fr-FR" smtClean="0"/>
+              <a:rPr lang="fr-FR"/>
               <a:t>Modifier les styles du texte du masque</a:t>
             </a:r>
           </a:p>
           <a:p>
             <a:pPr lvl="1"/>
             <a:r>
-              <a:rPr lang="fr-FR" smtClean="0"/>
+              <a:rPr lang="fr-FR"/>
               <a:t>Deuxième niveau</a:t>
             </a:r>
           </a:p>
           <a:p>
             <a:pPr lvl="2"/>
             <a:r>
-              <a:rPr lang="fr-FR" smtClean="0"/>
+              <a:rPr lang="fr-FR"/>
               <a:t>Troisième niveau</a:t>
             </a:r>
           </a:p>
           <a:p>
             <a:pPr lvl="3"/>
             <a:r>
-              <a:rPr lang="fr-FR" smtClean="0"/>
+              <a:rPr lang="fr-FR"/>
               <a:t>Quatrième niveau</a:t>
             </a:r>
           </a:p>
           <a:p>
             <a:pPr lvl="4"/>
             <a:r>
-              <a:rPr lang="fr-FR" smtClean="0"/>
+              <a:rPr lang="fr-FR"/>
               <a:t>Cinquième niveau</a:t>
             </a:r>
-            <a:endParaRPr lang="fr-FR"/>
           </a:p>
         </p:txBody>
       </p:sp>
@@ -1603,7 +1594,7 @@
           <a:p>
             <a:fld id="{3704A910-6F2B-4762-9270-65B2D88D615E}" type="datetimeFigureOut">
               <a:rPr lang="fr-FR" smtClean="0"/>
-              <a:t>30/09/2019</a:t>
+              <a:t>04/11/2019</a:t>
             </a:fld>
             <a:endParaRPr lang="fr-FR"/>
           </a:p>
@@ -1697,10 +1688,9 @@
           <a:lstStyle/>
           <a:p>
             <a:r>
-              <a:rPr lang="fr-FR" smtClean="0"/>
+              <a:rPr lang="fr-FR"/>
               <a:t>Modifiez le style du titre</a:t>
             </a:r>
-            <a:endParaRPr lang="fr-FR"/>
           </a:p>
         </p:txBody>
       </p:sp>
@@ -1721,7 +1711,7 @@
           <a:p>
             <a:fld id="{3704A910-6F2B-4762-9270-65B2D88D615E}" type="datetimeFigureOut">
               <a:rPr lang="fr-FR" smtClean="0"/>
-              <a:t>30/09/2019</a:t>
+              <a:t>04/11/2019</a:t>
             </a:fld>
             <a:endParaRPr lang="fr-FR"/>
           </a:p>
@@ -1816,7 +1806,7 @@
           <a:p>
             <a:fld id="{3704A910-6F2B-4762-9270-65B2D88D615E}" type="datetimeFigureOut">
               <a:rPr lang="fr-FR" smtClean="0"/>
-              <a:t>30/09/2019</a:t>
+              <a:t>04/11/2019</a:t>
             </a:fld>
             <a:endParaRPr lang="fr-FR"/>
           </a:p>
@@ -1919,10 +1909,9 @@
           </a:lstStyle>
           <a:p>
             <a:r>
-              <a:rPr lang="fr-FR" smtClean="0"/>
+              <a:rPr lang="fr-FR"/>
               <a:t>Modifiez le style du titre</a:t>
             </a:r>
-            <a:endParaRPr lang="fr-FR"/>
           </a:p>
         </p:txBody>
       </p:sp>
@@ -1976,38 +1965,37 @@
           <a:p>
             <a:pPr lvl="0"/>
             <a:r>
-              <a:rPr lang="fr-FR" smtClean="0"/>
+              <a:rPr lang="fr-FR"/>
               <a:t>Modifier les styles du texte du masque</a:t>
             </a:r>
           </a:p>
           <a:p>
             <a:pPr lvl="1"/>
             <a:r>
-              <a:rPr lang="fr-FR" smtClean="0"/>
+              <a:rPr lang="fr-FR"/>
               <a:t>Deuxième niveau</a:t>
             </a:r>
           </a:p>
           <a:p>
             <a:pPr lvl="2"/>
             <a:r>
-              <a:rPr lang="fr-FR" smtClean="0"/>
+              <a:rPr lang="fr-FR"/>
               <a:t>Troisième niveau</a:t>
             </a:r>
           </a:p>
           <a:p>
             <a:pPr lvl="3"/>
             <a:r>
-              <a:rPr lang="fr-FR" smtClean="0"/>
+              <a:rPr lang="fr-FR"/>
               <a:t>Quatrième niveau</a:t>
             </a:r>
           </a:p>
           <a:p>
             <a:pPr lvl="4"/>
             <a:r>
-              <a:rPr lang="fr-FR" smtClean="0"/>
+              <a:rPr lang="fr-FR"/>
               <a:t>Cinquième niveau</a:t>
             </a:r>
-            <a:endParaRPr lang="fr-FR"/>
           </a:p>
         </p:txBody>
       </p:sp>
@@ -2070,7 +2058,7 @@
           <a:p>
             <a:pPr lvl="0"/>
             <a:r>
-              <a:rPr lang="fr-FR" smtClean="0"/>
+              <a:rPr lang="fr-FR"/>
               <a:t>Modifier les styles du texte du masque</a:t>
             </a:r>
           </a:p>
@@ -2093,7 +2081,7 @@
           <a:p>
             <a:fld id="{3704A910-6F2B-4762-9270-65B2D88D615E}" type="datetimeFigureOut">
               <a:rPr lang="fr-FR" smtClean="0"/>
-              <a:t>30/09/2019</a:t>
+              <a:t>04/11/2019</a:t>
             </a:fld>
             <a:endParaRPr lang="fr-FR"/>
           </a:p>
@@ -2196,10 +2184,9 @@
           </a:lstStyle>
           <a:p>
             <a:r>
-              <a:rPr lang="fr-FR" smtClean="0"/>
+              <a:rPr lang="fr-FR"/>
               <a:t>Modifiez le style du titre</a:t>
             </a:r>
-            <a:endParaRPr lang="fr-FR"/>
           </a:p>
         </p:txBody>
       </p:sp>
@@ -2323,7 +2310,7 @@
           <a:p>
             <a:pPr lvl="0"/>
             <a:r>
-              <a:rPr lang="fr-FR" smtClean="0"/>
+              <a:rPr lang="fr-FR"/>
               <a:t>Modifier les styles du texte du masque</a:t>
             </a:r>
           </a:p>
@@ -2346,7 +2333,7 @@
           <a:p>
             <a:fld id="{3704A910-6F2B-4762-9270-65B2D88D615E}" type="datetimeFigureOut">
               <a:rPr lang="fr-FR" smtClean="0"/>
-              <a:t>30/09/2019</a:t>
+              <a:t>04/11/2019</a:t>
             </a:fld>
             <a:endParaRPr lang="fr-FR"/>
           </a:p>
@@ -2455,10 +2442,9 @@
           <a:lstStyle/>
           <a:p>
             <a:r>
-              <a:rPr lang="fr-FR" smtClean="0"/>
+              <a:rPr lang="fr-FR"/>
               <a:t>Modifiez le style du titre</a:t>
             </a:r>
-            <a:endParaRPr lang="fr-FR"/>
           </a:p>
         </p:txBody>
       </p:sp>
@@ -2489,38 +2475,37 @@
           <a:p>
             <a:pPr lvl="0"/>
             <a:r>
-              <a:rPr lang="fr-FR" smtClean="0"/>
+              <a:rPr lang="fr-FR"/>
               <a:t>Modifier les styles du texte du masque</a:t>
             </a:r>
           </a:p>
           <a:p>
             <a:pPr lvl="1"/>
             <a:r>
-              <a:rPr lang="fr-FR" smtClean="0"/>
+              <a:rPr lang="fr-FR"/>
               <a:t>Deuxième niveau</a:t>
             </a:r>
           </a:p>
           <a:p>
             <a:pPr lvl="2"/>
             <a:r>
-              <a:rPr lang="fr-FR" smtClean="0"/>
+              <a:rPr lang="fr-FR"/>
               <a:t>Troisième niveau</a:t>
             </a:r>
           </a:p>
           <a:p>
             <a:pPr lvl="3"/>
             <a:r>
-              <a:rPr lang="fr-FR" smtClean="0"/>
+              <a:rPr lang="fr-FR"/>
               <a:t>Quatrième niveau</a:t>
             </a:r>
           </a:p>
           <a:p>
             <a:pPr lvl="4"/>
             <a:r>
-              <a:rPr lang="fr-FR" smtClean="0"/>
+              <a:rPr lang="fr-FR"/>
               <a:t>Cinquième niveau</a:t>
             </a:r>
-            <a:endParaRPr lang="fr-FR"/>
           </a:p>
         </p:txBody>
       </p:sp>
@@ -2559,7 +2544,7 @@
           <a:p>
             <a:fld id="{3704A910-6F2B-4762-9270-65B2D88D615E}" type="datetimeFigureOut">
               <a:rPr lang="fr-FR" smtClean="0"/>
-              <a:t>30/09/2019</a:t>
+              <a:t>04/11/2019</a:t>
             </a:fld>
             <a:endParaRPr lang="fr-FR"/>
           </a:p>
@@ -4686,6 +4671,686 @@
 </p:sld>
 </file>
 
+<file path=ppt/slides/slide2.xml><?xml version="1.0" encoding="utf-8"?>
+<p:sld xmlns:a="http://schemas.openxmlformats.org/drawingml/2006/main" xmlns:r="http://schemas.openxmlformats.org/officeDocument/2006/relationships" xmlns:p="http://schemas.openxmlformats.org/presentationml/2006/main">
+  <p:cSld>
+    <p:spTree>
+      <p:nvGrpSpPr>
+        <p:cNvPr id="1" name=""/>
+        <p:cNvGrpSpPr/>
+        <p:nvPr/>
+      </p:nvGrpSpPr>
+      <p:grpSpPr>
+        <a:xfrm>
+          <a:off x="0" y="0"/>
+          <a:ext cx="0" cy="0"/>
+          <a:chOff x="0" y="0"/>
+          <a:chExt cx="0" cy="0"/>
+        </a:xfrm>
+      </p:grpSpPr>
+      <p:grpSp>
+        <p:nvGrpSpPr>
+          <p:cNvPr id="4" name="Groupe 3">
+            <a:extLst>
+              <a:ext uri="{FF2B5EF4-FFF2-40B4-BE49-F238E27FC236}">
+                <a16:creationId xmlns:a16="http://schemas.microsoft.com/office/drawing/2014/main" id="{B0A8BE06-17F7-614C-A028-4C309ED716A4}"/>
+              </a:ext>
+            </a:extLst>
+          </p:cNvPr>
+          <p:cNvGrpSpPr/>
+          <p:nvPr/>
+        </p:nvGrpSpPr>
+        <p:grpSpPr>
+          <a:xfrm>
+            <a:off x="4759546" y="3493661"/>
+            <a:ext cx="619528" cy="425742"/>
+            <a:chOff x="7022592" y="3486030"/>
+            <a:chExt cx="619528" cy="425742"/>
+          </a:xfrm>
+        </p:grpSpPr>
+        <p:sp>
+          <p:nvSpPr>
+            <p:cNvPr id="5" name="Rectangle 4">
+              <a:extLst>
+                <a:ext uri="{FF2B5EF4-FFF2-40B4-BE49-F238E27FC236}">
+                  <a16:creationId xmlns:a16="http://schemas.microsoft.com/office/drawing/2014/main" id="{26F521F2-EAFA-F74D-AA13-8ABE5703CBDC}"/>
+                </a:ext>
+              </a:extLst>
+            </p:cNvPr>
+            <p:cNvSpPr/>
+            <p:nvPr/>
+          </p:nvSpPr>
+          <p:spPr>
+            <a:xfrm rot="5400000">
+              <a:off x="7236344" y="3595884"/>
+              <a:ext cx="146304" cy="212871"/>
+            </a:xfrm>
+            <a:prstGeom prst="rect">
+              <a:avLst/>
+            </a:prstGeom>
+          </p:spPr>
+          <p:style>
+            <a:lnRef idx="2">
+              <a:schemeClr val="accent3">
+                <a:shade val="50000"/>
+              </a:schemeClr>
+            </a:lnRef>
+            <a:fillRef idx="1">
+              <a:schemeClr val="accent3"/>
+            </a:fillRef>
+            <a:effectRef idx="0">
+              <a:schemeClr val="accent3"/>
+            </a:effectRef>
+            <a:fontRef idx="minor">
+              <a:schemeClr val="lt1"/>
+            </a:fontRef>
+          </p:style>
+          <p:txBody>
+            <a:bodyPr rtlCol="0" anchor="ctr"/>
+            <a:lstStyle/>
+            <a:p>
+              <a:pPr algn="ctr"/>
+              <a:endParaRPr lang="fr-FR"/>
+            </a:p>
+          </p:txBody>
+        </p:sp>
+        <p:sp>
+          <p:nvSpPr>
+            <p:cNvPr id="6" name="Ellipse 5">
+              <a:extLst>
+                <a:ext uri="{FF2B5EF4-FFF2-40B4-BE49-F238E27FC236}">
+                  <a16:creationId xmlns:a16="http://schemas.microsoft.com/office/drawing/2014/main" id="{B8925D9D-CF0B-484D-9720-201D3B8F8D79}"/>
+                </a:ext>
+              </a:extLst>
+            </p:cNvPr>
+            <p:cNvSpPr/>
+            <p:nvPr/>
+          </p:nvSpPr>
+          <p:spPr>
+            <a:xfrm>
+              <a:off x="7367800" y="3571276"/>
+              <a:ext cx="274320" cy="274320"/>
+            </a:xfrm>
+            <a:prstGeom prst="ellipse">
+              <a:avLst/>
+            </a:prstGeom>
+          </p:spPr>
+          <p:style>
+            <a:lnRef idx="2">
+              <a:schemeClr val="accent3">
+                <a:shade val="50000"/>
+              </a:schemeClr>
+            </a:lnRef>
+            <a:fillRef idx="1">
+              <a:schemeClr val="accent3"/>
+            </a:fillRef>
+            <a:effectRef idx="0">
+              <a:schemeClr val="accent3"/>
+            </a:effectRef>
+            <a:fontRef idx="minor">
+              <a:schemeClr val="lt1"/>
+            </a:fontRef>
+          </p:style>
+          <p:txBody>
+            <a:bodyPr rtlCol="0" anchor="ctr"/>
+            <a:lstStyle/>
+            <a:p>
+              <a:pPr algn="ctr"/>
+              <a:endParaRPr lang="fr-FR"/>
+            </a:p>
+          </p:txBody>
+        </p:sp>
+        <p:sp>
+          <p:nvSpPr>
+            <p:cNvPr id="7" name="Rectangle 6">
+              <a:extLst>
+                <a:ext uri="{FF2B5EF4-FFF2-40B4-BE49-F238E27FC236}">
+                  <a16:creationId xmlns:a16="http://schemas.microsoft.com/office/drawing/2014/main" id="{1A4CB51A-640A-BF4F-AAE6-30E3994FA4F2}"/>
+                </a:ext>
+              </a:extLst>
+            </p:cNvPr>
+            <p:cNvSpPr/>
+            <p:nvPr/>
+          </p:nvSpPr>
+          <p:spPr>
+            <a:xfrm>
+              <a:off x="7022592" y="3486030"/>
+              <a:ext cx="228600" cy="425742"/>
+            </a:xfrm>
+            <a:prstGeom prst="rect">
+              <a:avLst/>
+            </a:prstGeom>
+          </p:spPr>
+          <p:style>
+            <a:lnRef idx="2">
+              <a:schemeClr val="accent3">
+                <a:shade val="50000"/>
+              </a:schemeClr>
+            </a:lnRef>
+            <a:fillRef idx="1">
+              <a:schemeClr val="accent3"/>
+            </a:fillRef>
+            <a:effectRef idx="0">
+              <a:schemeClr val="accent3"/>
+            </a:effectRef>
+            <a:fontRef idx="minor">
+              <a:schemeClr val="lt1"/>
+            </a:fontRef>
+          </p:style>
+          <p:txBody>
+            <a:bodyPr rtlCol="0" anchor="ctr"/>
+            <a:lstStyle/>
+            <a:p>
+              <a:pPr algn="ctr"/>
+              <a:endParaRPr lang="fr-FR"/>
+            </a:p>
+          </p:txBody>
+        </p:sp>
+      </p:grpSp>
+      <p:grpSp>
+        <p:nvGrpSpPr>
+          <p:cNvPr id="8" name="Groupe 7">
+            <a:extLst>
+              <a:ext uri="{FF2B5EF4-FFF2-40B4-BE49-F238E27FC236}">
+                <a16:creationId xmlns:a16="http://schemas.microsoft.com/office/drawing/2014/main" id="{BA9C21D0-12DA-654B-A6DF-FDD2FC852CD2}"/>
+              </a:ext>
+            </a:extLst>
+          </p:cNvPr>
+          <p:cNvGrpSpPr/>
+          <p:nvPr/>
+        </p:nvGrpSpPr>
+        <p:grpSpPr>
+          <a:xfrm>
+            <a:off x="2541232" y="3302638"/>
+            <a:ext cx="2338143" cy="2033821"/>
+            <a:chOff x="2541232" y="3302638"/>
+            <a:chExt cx="2338143" cy="2033821"/>
+          </a:xfrm>
+          <a:solidFill>
+            <a:srgbClr val="F17B41"/>
+          </a:solidFill>
+        </p:grpSpPr>
+        <p:sp>
+          <p:nvSpPr>
+            <p:cNvPr id="9" name="Rectangle 8">
+              <a:extLst>
+                <a:ext uri="{FF2B5EF4-FFF2-40B4-BE49-F238E27FC236}">
+                  <a16:creationId xmlns:a16="http://schemas.microsoft.com/office/drawing/2014/main" id="{B9CF1EE2-465F-DC41-A7D6-E2DDD3637D32}"/>
+                </a:ext>
+              </a:extLst>
+            </p:cNvPr>
+            <p:cNvSpPr/>
+            <p:nvPr/>
+          </p:nvSpPr>
+          <p:spPr>
+            <a:xfrm>
+              <a:off x="2798064" y="5111497"/>
+              <a:ext cx="950975" cy="224962"/>
+            </a:xfrm>
+            <a:prstGeom prst="rect">
+              <a:avLst/>
+            </a:prstGeom>
+            <a:grpFill/>
+            <a:ln>
+              <a:solidFill>
+                <a:srgbClr val="B1592D"/>
+              </a:solidFill>
+            </a:ln>
+          </p:spPr>
+          <p:style>
+            <a:lnRef idx="2">
+              <a:schemeClr val="accent2">
+                <a:shade val="50000"/>
+              </a:schemeClr>
+            </a:lnRef>
+            <a:fillRef idx="1">
+              <a:schemeClr val="accent2"/>
+            </a:fillRef>
+            <a:effectRef idx="0">
+              <a:schemeClr val="accent2"/>
+            </a:effectRef>
+            <a:fontRef idx="minor">
+              <a:schemeClr val="lt1"/>
+            </a:fontRef>
+          </p:style>
+          <p:txBody>
+            <a:bodyPr rtlCol="0" anchor="ctr"/>
+            <a:lstStyle/>
+            <a:p>
+              <a:pPr algn="ctr"/>
+              <a:endParaRPr lang="fr-FR"/>
+            </a:p>
+          </p:txBody>
+        </p:sp>
+        <p:sp>
+          <p:nvSpPr>
+            <p:cNvPr id="10" name="Rectangle 9">
+              <a:extLst>
+                <a:ext uri="{FF2B5EF4-FFF2-40B4-BE49-F238E27FC236}">
+                  <a16:creationId xmlns:a16="http://schemas.microsoft.com/office/drawing/2014/main" id="{183D0C48-3363-3B4C-A25D-0CEF0399F7C7}"/>
+                </a:ext>
+              </a:extLst>
+            </p:cNvPr>
+            <p:cNvSpPr/>
+            <p:nvPr/>
+          </p:nvSpPr>
+          <p:spPr>
+            <a:xfrm rot="13787616">
+              <a:off x="2620561" y="4467163"/>
+              <a:ext cx="902046" cy="364472"/>
+            </a:xfrm>
+            <a:prstGeom prst="rect">
+              <a:avLst/>
+            </a:prstGeom>
+            <a:grpFill/>
+            <a:ln>
+              <a:solidFill>
+                <a:srgbClr val="B1592D"/>
+              </a:solidFill>
+            </a:ln>
+          </p:spPr>
+          <p:style>
+            <a:lnRef idx="2">
+              <a:schemeClr val="accent2">
+                <a:shade val="50000"/>
+              </a:schemeClr>
+            </a:lnRef>
+            <a:fillRef idx="1">
+              <a:schemeClr val="accent2"/>
+            </a:fillRef>
+            <a:effectRef idx="0">
+              <a:schemeClr val="accent2"/>
+            </a:effectRef>
+            <a:fontRef idx="minor">
+              <a:schemeClr val="lt1"/>
+            </a:fontRef>
+          </p:style>
+          <p:txBody>
+            <a:bodyPr rtlCol="0" anchor="ctr"/>
+            <a:lstStyle/>
+            <a:p>
+              <a:pPr algn="ctr"/>
+              <a:endParaRPr lang="fr-FR"/>
+            </a:p>
+          </p:txBody>
+        </p:sp>
+        <p:sp>
+          <p:nvSpPr>
+            <p:cNvPr id="11" name="Rectangle 10">
+              <a:extLst>
+                <a:ext uri="{FF2B5EF4-FFF2-40B4-BE49-F238E27FC236}">
+                  <a16:creationId xmlns:a16="http://schemas.microsoft.com/office/drawing/2014/main" id="{D49487E0-15A6-3440-9915-006FA75D6BA3}"/>
+                </a:ext>
+              </a:extLst>
+            </p:cNvPr>
+            <p:cNvSpPr/>
+            <p:nvPr/>
+          </p:nvSpPr>
+          <p:spPr>
+            <a:xfrm rot="19750510">
+              <a:off x="2638674" y="3671163"/>
+              <a:ext cx="1358573" cy="364472"/>
+            </a:xfrm>
+            <a:prstGeom prst="rect">
+              <a:avLst/>
+            </a:prstGeom>
+            <a:grpFill/>
+            <a:ln>
+              <a:solidFill>
+                <a:srgbClr val="B1592D"/>
+              </a:solidFill>
+            </a:ln>
+          </p:spPr>
+          <p:style>
+            <a:lnRef idx="2">
+              <a:schemeClr val="accent2">
+                <a:shade val="50000"/>
+              </a:schemeClr>
+            </a:lnRef>
+            <a:fillRef idx="1">
+              <a:schemeClr val="accent2"/>
+            </a:fillRef>
+            <a:effectRef idx="0">
+              <a:schemeClr val="accent2"/>
+            </a:effectRef>
+            <a:fontRef idx="minor">
+              <a:schemeClr val="lt1"/>
+            </a:fontRef>
+          </p:style>
+          <p:txBody>
+            <a:bodyPr rtlCol="0" anchor="ctr"/>
+            <a:lstStyle/>
+            <a:p>
+              <a:pPr algn="ctr"/>
+              <a:endParaRPr lang="fr-FR"/>
+            </a:p>
+          </p:txBody>
+        </p:sp>
+        <p:sp>
+          <p:nvSpPr>
+            <p:cNvPr id="12" name="Rectangle 11">
+              <a:extLst>
+                <a:ext uri="{FF2B5EF4-FFF2-40B4-BE49-F238E27FC236}">
+                  <a16:creationId xmlns:a16="http://schemas.microsoft.com/office/drawing/2014/main" id="{A04FA101-05D9-804B-8BA3-BD9DCA9192C4}"/>
+                </a:ext>
+              </a:extLst>
+            </p:cNvPr>
+            <p:cNvSpPr/>
+            <p:nvPr/>
+          </p:nvSpPr>
+          <p:spPr>
+            <a:xfrm rot="1109954">
+              <a:off x="3896159" y="3446931"/>
+              <a:ext cx="677727" cy="364472"/>
+            </a:xfrm>
+            <a:prstGeom prst="rect">
+              <a:avLst/>
+            </a:prstGeom>
+            <a:grpFill/>
+            <a:ln>
+              <a:solidFill>
+                <a:srgbClr val="B1592D"/>
+              </a:solidFill>
+            </a:ln>
+          </p:spPr>
+          <p:style>
+            <a:lnRef idx="2">
+              <a:schemeClr val="accent2">
+                <a:shade val="50000"/>
+              </a:schemeClr>
+            </a:lnRef>
+            <a:fillRef idx="1">
+              <a:schemeClr val="accent2"/>
+            </a:fillRef>
+            <a:effectRef idx="0">
+              <a:schemeClr val="accent2"/>
+            </a:effectRef>
+            <a:fontRef idx="minor">
+              <a:schemeClr val="lt1"/>
+            </a:fontRef>
+          </p:style>
+          <p:txBody>
+            <a:bodyPr rtlCol="0" anchor="ctr"/>
+            <a:lstStyle/>
+            <a:p>
+              <a:pPr algn="ctr"/>
+              <a:endParaRPr lang="fr-FR"/>
+            </a:p>
+          </p:txBody>
+        </p:sp>
+        <p:sp>
+          <p:nvSpPr>
+            <p:cNvPr id="13" name="Ellipse 12">
+              <a:extLst>
+                <a:ext uri="{FF2B5EF4-FFF2-40B4-BE49-F238E27FC236}">
+                  <a16:creationId xmlns:a16="http://schemas.microsoft.com/office/drawing/2014/main" id="{AE18BDD5-1F5A-8D49-A22A-BD8602BBAD44}"/>
+                </a:ext>
+              </a:extLst>
+            </p:cNvPr>
+            <p:cNvSpPr/>
+            <p:nvPr/>
+          </p:nvSpPr>
+          <p:spPr>
+            <a:xfrm>
+              <a:off x="2541232" y="3939204"/>
+              <a:ext cx="530352" cy="530352"/>
+            </a:xfrm>
+            <a:prstGeom prst="ellipse">
+              <a:avLst/>
+            </a:prstGeom>
+            <a:grpFill/>
+            <a:ln>
+              <a:solidFill>
+                <a:srgbClr val="B1592D"/>
+              </a:solidFill>
+            </a:ln>
+          </p:spPr>
+          <p:style>
+            <a:lnRef idx="2">
+              <a:schemeClr val="accent2">
+                <a:shade val="50000"/>
+              </a:schemeClr>
+            </a:lnRef>
+            <a:fillRef idx="1">
+              <a:schemeClr val="accent2"/>
+            </a:fillRef>
+            <a:effectRef idx="0">
+              <a:schemeClr val="accent2"/>
+            </a:effectRef>
+            <a:fontRef idx="minor">
+              <a:schemeClr val="lt1"/>
+            </a:fontRef>
+          </p:style>
+          <p:txBody>
+            <a:bodyPr rtlCol="0" anchor="ctr"/>
+            <a:lstStyle/>
+            <a:p>
+              <a:pPr algn="ctr"/>
+              <a:endParaRPr lang="fr-FR"/>
+            </a:p>
+          </p:txBody>
+        </p:sp>
+        <p:sp>
+          <p:nvSpPr>
+            <p:cNvPr id="14" name="Ellipse 13">
+              <a:extLst>
+                <a:ext uri="{FF2B5EF4-FFF2-40B4-BE49-F238E27FC236}">
+                  <a16:creationId xmlns:a16="http://schemas.microsoft.com/office/drawing/2014/main" id="{EF7F0487-63C5-E241-AC61-889BBAC262D7}"/>
+                </a:ext>
+              </a:extLst>
+            </p:cNvPr>
+            <p:cNvSpPr/>
+            <p:nvPr/>
+          </p:nvSpPr>
+          <p:spPr>
+            <a:xfrm>
+              <a:off x="3006711" y="4735288"/>
+              <a:ext cx="530352" cy="530352"/>
+            </a:xfrm>
+            <a:prstGeom prst="ellipse">
+              <a:avLst/>
+            </a:prstGeom>
+            <a:grpFill/>
+            <a:ln>
+              <a:solidFill>
+                <a:srgbClr val="B1592D"/>
+              </a:solidFill>
+            </a:ln>
+          </p:spPr>
+          <p:style>
+            <a:lnRef idx="2">
+              <a:schemeClr val="accent2">
+                <a:shade val="50000"/>
+              </a:schemeClr>
+            </a:lnRef>
+            <a:fillRef idx="1">
+              <a:schemeClr val="accent2"/>
+            </a:fillRef>
+            <a:effectRef idx="0">
+              <a:schemeClr val="accent2"/>
+            </a:effectRef>
+            <a:fontRef idx="minor">
+              <a:schemeClr val="lt1"/>
+            </a:fontRef>
+          </p:style>
+          <p:txBody>
+            <a:bodyPr rtlCol="0" anchor="ctr"/>
+            <a:lstStyle/>
+            <a:p>
+              <a:pPr algn="ctr"/>
+              <a:endParaRPr lang="fr-FR"/>
+            </a:p>
+          </p:txBody>
+        </p:sp>
+        <p:sp>
+          <p:nvSpPr>
+            <p:cNvPr id="15" name="Ellipse 14">
+              <a:extLst>
+                <a:ext uri="{FF2B5EF4-FFF2-40B4-BE49-F238E27FC236}">
+                  <a16:creationId xmlns:a16="http://schemas.microsoft.com/office/drawing/2014/main" id="{DDEDECAD-AE9A-C34D-B2EB-BB942CFF24CE}"/>
+                </a:ext>
+              </a:extLst>
+            </p:cNvPr>
+            <p:cNvSpPr/>
+            <p:nvPr/>
+          </p:nvSpPr>
+          <p:spPr>
+            <a:xfrm>
+              <a:off x="3608392" y="3302638"/>
+              <a:ext cx="530352" cy="530352"/>
+            </a:xfrm>
+            <a:prstGeom prst="ellipse">
+              <a:avLst/>
+            </a:prstGeom>
+            <a:grpFill/>
+            <a:ln>
+              <a:solidFill>
+                <a:srgbClr val="B1592D"/>
+              </a:solidFill>
+            </a:ln>
+          </p:spPr>
+          <p:style>
+            <a:lnRef idx="2">
+              <a:schemeClr val="accent2">
+                <a:shade val="50000"/>
+              </a:schemeClr>
+            </a:lnRef>
+            <a:fillRef idx="1">
+              <a:schemeClr val="accent2"/>
+            </a:fillRef>
+            <a:effectRef idx="0">
+              <a:schemeClr val="accent2"/>
+            </a:effectRef>
+            <a:fontRef idx="minor">
+              <a:schemeClr val="lt1"/>
+            </a:fontRef>
+          </p:style>
+          <p:txBody>
+            <a:bodyPr rtlCol="0" anchor="ctr"/>
+            <a:lstStyle/>
+            <a:p>
+              <a:pPr algn="ctr"/>
+              <a:endParaRPr lang="fr-FR"/>
+            </a:p>
+          </p:txBody>
+        </p:sp>
+        <p:sp>
+          <p:nvSpPr>
+            <p:cNvPr id="16" name="Ellipse 15">
+              <a:extLst>
+                <a:ext uri="{FF2B5EF4-FFF2-40B4-BE49-F238E27FC236}">
+                  <a16:creationId xmlns:a16="http://schemas.microsoft.com/office/drawing/2014/main" id="{F539190E-DEA0-C84F-9D22-DC668FE7393F}"/>
+                </a:ext>
+              </a:extLst>
+            </p:cNvPr>
+            <p:cNvSpPr/>
+            <p:nvPr/>
+          </p:nvSpPr>
+          <p:spPr>
+            <a:xfrm>
+              <a:off x="4349023" y="3445775"/>
+              <a:ext cx="530352" cy="530352"/>
+            </a:xfrm>
+            <a:prstGeom prst="ellipse">
+              <a:avLst/>
+            </a:prstGeom>
+            <a:grpFill/>
+            <a:ln>
+              <a:solidFill>
+                <a:srgbClr val="B1592D"/>
+              </a:solidFill>
+            </a:ln>
+          </p:spPr>
+          <p:style>
+            <a:lnRef idx="2">
+              <a:schemeClr val="accent2">
+                <a:shade val="50000"/>
+              </a:schemeClr>
+            </a:lnRef>
+            <a:fillRef idx="1">
+              <a:schemeClr val="accent2"/>
+            </a:fillRef>
+            <a:effectRef idx="0">
+              <a:schemeClr val="accent2"/>
+            </a:effectRef>
+            <a:fontRef idx="minor">
+              <a:schemeClr val="lt1"/>
+            </a:fontRef>
+          </p:style>
+          <p:txBody>
+            <a:bodyPr rtlCol="0" anchor="ctr"/>
+            <a:lstStyle/>
+            <a:p>
+              <a:pPr algn="ctr"/>
+              <a:endParaRPr lang="fr-FR"/>
+            </a:p>
+          </p:txBody>
+        </p:sp>
+      </p:grpSp>
+      <p:sp>
+        <p:nvSpPr>
+          <p:cNvPr id="17" name="Rectangle 16">
+            <a:extLst>
+              <a:ext uri="{FF2B5EF4-FFF2-40B4-BE49-F238E27FC236}">
+                <a16:creationId xmlns:a16="http://schemas.microsoft.com/office/drawing/2014/main" id="{66401837-DB40-8D4B-BD05-10614CDF7F93}"/>
+              </a:ext>
+            </a:extLst>
+          </p:cNvPr>
+          <p:cNvSpPr/>
+          <p:nvPr/>
+        </p:nvSpPr>
+        <p:spPr>
+          <a:xfrm>
+            <a:off x="2664889" y="5349230"/>
+            <a:ext cx="1229471" cy="328172"/>
+          </a:xfrm>
+          <a:prstGeom prst="rect">
+            <a:avLst/>
+          </a:prstGeom>
+          <a:solidFill>
+            <a:schemeClr val="bg2">
+              <a:lumMod val="25000"/>
+            </a:schemeClr>
+          </a:solidFill>
+        </p:spPr>
+        <p:style>
+          <a:lnRef idx="2">
+            <a:schemeClr val="dk1">
+              <a:shade val="50000"/>
+            </a:schemeClr>
+          </a:lnRef>
+          <a:fillRef idx="1">
+            <a:schemeClr val="dk1"/>
+          </a:fillRef>
+          <a:effectRef idx="0">
+            <a:schemeClr val="dk1"/>
+          </a:effectRef>
+          <a:fontRef idx="minor">
+            <a:schemeClr val="lt1"/>
+          </a:fontRef>
+        </p:style>
+        <p:txBody>
+          <a:bodyPr rtlCol="0" anchor="ctr"/>
+          <a:lstStyle/>
+          <a:p>
+            <a:pPr algn="ctr"/>
+            <a:endParaRPr lang="fr-FR"/>
+          </a:p>
+        </p:txBody>
+      </p:sp>
+    </p:spTree>
+    <p:extLst>
+      <p:ext uri="{BB962C8B-B14F-4D97-AF65-F5344CB8AC3E}">
+        <p14:creationId xmlns:p14="http://schemas.microsoft.com/office/powerpoint/2010/main" val="1056155753"/>
+      </p:ext>
+    </p:extLst>
+  </p:cSld>
+  <p:clrMapOvr>
+    <a:masterClrMapping/>
+  </p:clrMapOvr>
+</p:sld>
+</file>
+
 <file path=ppt/theme/theme1.xml><?xml version="1.0" encoding="utf-8"?>
 <a:theme xmlns:a="http://schemas.openxmlformats.org/drawingml/2006/main" name="Thème Office">
   <a:themeElements>

</xml_diff>